<commit_message>
docs: finalize project submission package
</commit_message>
<xml_diff>
--- a/docs/Final-Project-Presentation.pptx
+++ b/docs/Final-Project-Presentation.pptx
@@ -2,20 +2,20 @@
 <file path=ppt/presentation.xml><?xml version="1.0" encoding="utf-8"?>
 <p:presentation xmlns:p="http://schemas.openxmlformats.org/presentationml/2006/main">
   <p:sldMasterIdLst>
-    <p:sldMasterId xmlns:r="http://schemas.openxmlformats.org/officeDocument/2006/relationships" id="2147483648" r:id="R79d156d2507845f0"/>
+    <p:sldMasterId xmlns:r="http://schemas.openxmlformats.org/officeDocument/2006/relationships" id="2147483648" r:id="Re1d0df8e6ed044f1"/>
   </p:sldMasterIdLst>
   <p:notesMasterIdLst>
-    <p:notesMasterId xmlns:r="http://schemas.openxmlformats.org/officeDocument/2006/relationships" r:id="R92e4becbda2a4de6"/>
+    <p:notesMasterId xmlns:r="http://schemas.openxmlformats.org/officeDocument/2006/relationships" r:id="Ra8a7a46d0141410b"/>
   </p:notesMasterIdLst>
   <p:sldIdLst>
-    <p:sldId xmlns:r="http://schemas.openxmlformats.org/officeDocument/2006/relationships" id="256" r:id="R9e7a844a0faf4c2e"/>
-    <p:sldId xmlns:r="http://schemas.openxmlformats.org/officeDocument/2006/relationships" id="257" r:id="R12573f48cb09428b"/>
-    <p:sldId xmlns:r="http://schemas.openxmlformats.org/officeDocument/2006/relationships" id="258" r:id="R3271dba1dbbe4b55"/>
-    <p:sldId xmlns:r="http://schemas.openxmlformats.org/officeDocument/2006/relationships" id="259" r:id="Re4678fb46e154be0"/>
-    <p:sldId xmlns:r="http://schemas.openxmlformats.org/officeDocument/2006/relationships" id="260" r:id="R81b21e668fc543e8"/>
-    <p:sldId xmlns:r="http://schemas.openxmlformats.org/officeDocument/2006/relationships" id="261" r:id="Rbec89637cc184d94"/>
-    <p:sldId xmlns:r="http://schemas.openxmlformats.org/officeDocument/2006/relationships" id="262" r:id="R8577f610b2154072"/>
-    <p:sldId xmlns:r="http://schemas.openxmlformats.org/officeDocument/2006/relationships" id="263" r:id="Ree602c02fe2e474e"/>
+    <p:sldId xmlns:r="http://schemas.openxmlformats.org/officeDocument/2006/relationships" id="256" r:id="R253eb1c984224807"/>
+    <p:sldId xmlns:r="http://schemas.openxmlformats.org/officeDocument/2006/relationships" id="257" r:id="Ra92e4ab51056410b"/>
+    <p:sldId xmlns:r="http://schemas.openxmlformats.org/officeDocument/2006/relationships" id="258" r:id="R67ed24d38d63420a"/>
+    <p:sldId xmlns:r="http://schemas.openxmlformats.org/officeDocument/2006/relationships" id="259" r:id="R06fa18331b8c43e6"/>
+    <p:sldId xmlns:r="http://schemas.openxmlformats.org/officeDocument/2006/relationships" id="260" r:id="R303d579cbec6463a"/>
+    <p:sldId xmlns:r="http://schemas.openxmlformats.org/officeDocument/2006/relationships" id="261" r:id="Rbe2002f70c8b4688"/>
+    <p:sldId xmlns:r="http://schemas.openxmlformats.org/officeDocument/2006/relationships" id="262" r:id="R2d0dc03dc75140fa"/>
+    <p:sldId xmlns:r="http://schemas.openxmlformats.org/officeDocument/2006/relationships" id="263" r:id="R27c72b93b6fb416d"/>
   </p:sldIdLst>
   <p:sldSz cx="12192000" cy="6858000"/>
   <p:notesSz cx="6858000" cy="9144000"/>
@@ -1137,7 +1137,7 @@
   </p:cSld>
   <p:clrMap bg1="lt1" tx1="dk1" bg2="lt2" tx2="dk2" accent1="accent1" accent2="accent2" accent3="accent3" accent4="accent4" accent5="accent5" accent6="accent6" hlink="hlink" folHlink="folHlink"/>
   <p:sldLayoutIdLst>
-    <p:sldLayoutId xmlns:r="http://schemas.openxmlformats.org/officeDocument/2006/relationships" id="2147483649" r:id="R7a7c0d53862d498b"/>
+    <p:sldLayoutId xmlns:r="http://schemas.openxmlformats.org/officeDocument/2006/relationships" id="2147483649" r:id="R49d105e1fd46465f"/>
   </p:sldLayoutIdLst>
   <p:txStyles>
     <p:titleStyle>
@@ -1706,10 +1706,10 @@
                 <c:v>1185</c:v>
               </c:pt>
               <c:pt idx="1">
-                <c:v>481</c:v>
+                <c:v>581</c:v>
               </c:pt>
               <c:pt idx="2">
-                <c:v>6</c:v>
+                <c:v>11</c:v>
               </c:pt>
             </c:numLit>
           </c:val>
@@ -1892,22 +1892,22 @@
               <c:formatCode>General</c:formatCode>
               <c:ptCount val="6"/>
               <c:pt idx="0">
-                <c:v>71.2</c:v>
+                <c:v>70.2</c:v>
               </c:pt>
               <c:pt idx="1">
-                <c:v>69.3</c:v>
+                <c:v>58.8</c:v>
               </c:pt>
               <c:pt idx="2">
-                <c:v>69.1</c:v>
+                <c:v>58.7</c:v>
               </c:pt>
               <c:pt idx="3">
-                <c:v>59.2</c:v>
+                <c:v>57.2</c:v>
               </c:pt>
               <c:pt idx="4">
-                <c:v>51.2</c:v>
+                <c:v>52.4</c:v>
               </c:pt>
               <c:pt idx="5">
-                <c:v>48.6</c:v>
+                <c:v>51.6</c:v>
               </c:pt>
             </c:numLit>
           </c:val>
@@ -2482,6 +2482,7 @@
           <a:lstStyle xmlns:a="http://schemas.openxmlformats.org/drawingml/2006/main"/>
           <a:p xmlns:a="http://schemas.openxmlformats.org/drawingml/2006/main">
             <a:pPr algn="l">
+              <a:buNone/>
               <a:defRPr sz="1350" b="1">
                 <a:solidFill>
                   <a:srgbClr val="3D8DFF"/>
@@ -2540,6 +2541,7 @@
           <a:lstStyle xmlns:a="http://schemas.openxmlformats.org/drawingml/2006/main"/>
           <a:p xmlns:a="http://schemas.openxmlformats.org/drawingml/2006/main">
             <a:pPr algn="l">
+              <a:buNone/>
               <a:defRPr sz="4350" b="1">
                 <a:solidFill>
                   <a:srgbClr val="000000"/>
@@ -2563,6 +2565,7 @@
           </a:p>
           <a:p xmlns:a="http://schemas.openxmlformats.org/drawingml/2006/main">
             <a:pPr algn="l">
+              <a:buNone/>
               <a:defRPr sz="4350" b="1">
                 <a:solidFill>
                   <a:srgbClr val="000000"/>
@@ -2621,6 +2624,7 @@
           <a:lstStyle xmlns:a="http://schemas.openxmlformats.org/drawingml/2006/main"/>
           <a:p xmlns:a="http://schemas.openxmlformats.org/drawingml/2006/main">
             <a:pPr algn="l">
+              <a:buNone/>
               <a:defRPr sz="2100" b="1">
                 <a:solidFill>
                   <a:srgbClr val="000000"/>
@@ -2679,6 +2683,7 @@
           <a:lstStyle xmlns:a="http://schemas.openxmlformats.org/drawingml/2006/main"/>
           <a:p xmlns:a="http://schemas.openxmlformats.org/drawingml/2006/main">
             <a:pPr algn="l">
+              <a:buNone/>
               <a:defRPr sz="1725" b="0">
                 <a:solidFill>
                   <a:srgbClr val="5B6470"/>
@@ -2737,6 +2742,7 @@
           <a:lstStyle xmlns:a="http://schemas.openxmlformats.org/drawingml/2006/main"/>
           <a:p xmlns:a="http://schemas.openxmlformats.org/drawingml/2006/main">
             <a:pPr algn="l">
+              <a:buNone/>
               <a:defRPr sz="1275" b="0">
                 <a:solidFill>
                   <a:srgbClr val="5B6470"/>
@@ -2755,7 +2761,7 @@
                 <a:ea typeface="Arial"/>
                 <a:cs typeface="Arial"/>
               </a:rPr>
-              <a:t>17 August 2026</a:t>
+              <a:t>3 September 2026</a:t>
             </a:r>
           </a:p>
         </p:txBody>
@@ -2824,6 +2830,7 @@
           <a:lstStyle xmlns:a="http://schemas.openxmlformats.org/drawingml/2006/main"/>
           <a:p xmlns:a="http://schemas.openxmlformats.org/drawingml/2006/main">
             <a:pPr algn="l">
+              <a:buNone/>
               <a:defRPr sz="3150" b="1">
                 <a:solidFill>
                   <a:srgbClr val="000000"/>
@@ -2882,6 +2889,7 @@
           <a:lstStyle xmlns:a="http://schemas.openxmlformats.org/drawingml/2006/main"/>
           <a:p xmlns:a="http://schemas.openxmlformats.org/drawingml/2006/main">
             <a:pPr algn="r">
+              <a:buNone/>
               <a:defRPr sz="975" b="0">
                 <a:solidFill>
                   <a:srgbClr val="5B6470"/>
@@ -2971,6 +2979,7 @@
           <a:lstStyle xmlns:a="http://schemas.openxmlformats.org/drawingml/2006/main"/>
           <a:p xmlns:a="http://schemas.openxmlformats.org/drawingml/2006/main">
             <a:pPr algn="l">
+              <a:buNone/>
               <a:defRPr sz="2550" b="1">
                 <a:solidFill>
                   <a:srgbClr val="3D8DFF"/>
@@ -3029,6 +3038,7 @@
           <a:lstStyle xmlns:a="http://schemas.openxmlformats.org/drawingml/2006/main"/>
           <a:p xmlns:a="http://schemas.openxmlformats.org/drawingml/2006/main">
             <a:pPr algn="l">
+              <a:buNone/>
               <a:defRPr sz="2100" b="1">
                 <a:solidFill>
                   <a:srgbClr val="000000"/>
@@ -3087,6 +3097,7 @@
           <a:lstStyle xmlns:a="http://schemas.openxmlformats.org/drawingml/2006/main"/>
           <a:p xmlns:a="http://schemas.openxmlformats.org/drawingml/2006/main">
             <a:pPr algn="l">
+              <a:buNone/>
               <a:defRPr sz="1500" b="0">
                 <a:solidFill>
                   <a:srgbClr val="5B6470"/>
@@ -3176,6 +3187,7 @@
           <a:lstStyle xmlns:a="http://schemas.openxmlformats.org/drawingml/2006/main"/>
           <a:p xmlns:a="http://schemas.openxmlformats.org/drawingml/2006/main">
             <a:pPr algn="l">
+              <a:buNone/>
               <a:defRPr sz="2550" b="1">
                 <a:solidFill>
                   <a:srgbClr val="3D8DFF"/>
@@ -3234,6 +3246,7 @@
           <a:lstStyle xmlns:a="http://schemas.openxmlformats.org/drawingml/2006/main"/>
           <a:p xmlns:a="http://schemas.openxmlformats.org/drawingml/2006/main">
             <a:pPr algn="l">
+              <a:buNone/>
               <a:defRPr sz="2100" b="1">
                 <a:solidFill>
                   <a:srgbClr val="000000"/>
@@ -3292,6 +3305,7 @@
           <a:lstStyle xmlns:a="http://schemas.openxmlformats.org/drawingml/2006/main"/>
           <a:p xmlns:a="http://schemas.openxmlformats.org/drawingml/2006/main">
             <a:pPr algn="l">
+              <a:buNone/>
               <a:defRPr sz="1500" b="0">
                 <a:solidFill>
                   <a:srgbClr val="5B6470"/>
@@ -3381,6 +3395,7 @@
           <a:lstStyle xmlns:a="http://schemas.openxmlformats.org/drawingml/2006/main"/>
           <a:p xmlns:a="http://schemas.openxmlformats.org/drawingml/2006/main">
             <a:pPr algn="l">
+              <a:buNone/>
               <a:defRPr sz="2550" b="1">
                 <a:solidFill>
                   <a:srgbClr val="3D8DFF"/>
@@ -3439,6 +3454,7 @@
           <a:lstStyle xmlns:a="http://schemas.openxmlformats.org/drawingml/2006/main"/>
           <a:p xmlns:a="http://schemas.openxmlformats.org/drawingml/2006/main">
             <a:pPr algn="l">
+              <a:buNone/>
               <a:defRPr sz="2100" b="1">
                 <a:solidFill>
                   <a:srgbClr val="000000"/>
@@ -3497,6 +3513,7 @@
           <a:lstStyle xmlns:a="http://schemas.openxmlformats.org/drawingml/2006/main"/>
           <a:p xmlns:a="http://schemas.openxmlformats.org/drawingml/2006/main">
             <a:pPr algn="l">
+              <a:buNone/>
               <a:defRPr sz="1500" b="0">
                 <a:solidFill>
                   <a:srgbClr val="5B6470"/>
@@ -3586,6 +3603,7 @@
           <a:lstStyle xmlns:a="http://schemas.openxmlformats.org/drawingml/2006/main"/>
           <a:p xmlns:a="http://schemas.openxmlformats.org/drawingml/2006/main">
             <a:pPr algn="l">
+              <a:buNone/>
               <a:defRPr sz="2550" b="1">
                 <a:solidFill>
                   <a:srgbClr val="3D8DFF"/>
@@ -3644,6 +3662,7 @@
           <a:lstStyle xmlns:a="http://schemas.openxmlformats.org/drawingml/2006/main"/>
           <a:p xmlns:a="http://schemas.openxmlformats.org/drawingml/2006/main">
             <a:pPr algn="l">
+              <a:buNone/>
               <a:defRPr sz="2100" b="1">
                 <a:solidFill>
                   <a:srgbClr val="000000"/>
@@ -3702,6 +3721,7 @@
           <a:lstStyle xmlns:a="http://schemas.openxmlformats.org/drawingml/2006/main"/>
           <a:p xmlns:a="http://schemas.openxmlformats.org/drawingml/2006/main">
             <a:pPr algn="l">
+              <a:buNone/>
               <a:defRPr sz="1500" b="0">
                 <a:solidFill>
                   <a:srgbClr val="5B6470"/>
@@ -3760,6 +3780,7 @@
           <a:lstStyle xmlns:a="http://schemas.openxmlformats.org/drawingml/2006/main"/>
           <a:p xmlns:a="http://schemas.openxmlformats.org/drawingml/2006/main">
             <a:pPr algn="l">
+              <a:buNone/>
               <a:defRPr sz="1350" b="1">
                 <a:solidFill>
                   <a:srgbClr val="3D8DFF"/>
@@ -3818,6 +3839,7 @@
           <a:lstStyle xmlns:a="http://schemas.openxmlformats.org/drawingml/2006/main"/>
           <a:p xmlns:a="http://schemas.openxmlformats.org/drawingml/2006/main">
             <a:pPr algn="l">
+              <a:buNone/>
               <a:defRPr sz="1950" b="1">
                 <a:solidFill>
                   <a:srgbClr val="000000"/>
@@ -3905,6 +3927,7 @@
           <a:lstStyle xmlns:a="http://schemas.openxmlformats.org/drawingml/2006/main"/>
           <a:p xmlns:a="http://schemas.openxmlformats.org/drawingml/2006/main">
             <a:pPr algn="l">
+              <a:buNone/>
               <a:defRPr sz="3150" b="1">
                 <a:solidFill>
                   <a:srgbClr val="000000"/>
@@ -3963,6 +3986,7 @@
           <a:lstStyle xmlns:a="http://schemas.openxmlformats.org/drawingml/2006/main"/>
           <a:p xmlns:a="http://schemas.openxmlformats.org/drawingml/2006/main">
             <a:pPr algn="r">
+              <a:buNone/>
               <a:defRPr sz="975" b="0">
                 <a:solidFill>
                   <a:srgbClr val="5B6470"/>
@@ -3988,7 +4012,7 @@
       </p:sp>
       <p:graphicFrame>
         <p:nvGraphicFramePr>
-          <p:cNvPr id="13" name="Chart"/>
+          <p:cNvPr id="15" name="Chart"/>
           <p:cNvGraphicFramePr/>
           <p:nvPr/>
         </p:nvGraphicFramePr>
@@ -3998,7 +4022,7 @@
         </p:xfrm>
         <a:graphic xmlns:a="http://schemas.openxmlformats.org/drawingml/2006/main">
           <a:graphicData uri="http://schemas.openxmlformats.org/drawingml/2006/chart">
-            <c:chart xmlns:r="http://schemas.openxmlformats.org/officeDocument/2006/relationships" xmlns:c="http://schemas.openxmlformats.org/drawingml/2006/chart" r:id="Rbb41a94fffdd4aac"/>
+            <c:chart xmlns:r="http://schemas.openxmlformats.org/officeDocument/2006/relationships" xmlns:c="http://schemas.openxmlformats.org/drawingml/2006/chart" r:id="R2af5964425434b57"/>
           </a:graphicData>
         </a:graphic>
       </p:graphicFrame>
@@ -4068,6 +4092,7 @@
           <a:lstStyle xmlns:a="http://schemas.openxmlformats.org/drawingml/2006/main"/>
           <a:p xmlns:a="http://schemas.openxmlformats.org/drawingml/2006/main">
             <a:pPr algn="l">
+              <a:buNone/>
               <a:defRPr sz="2550" b="1">
                 <a:solidFill>
                   <a:srgbClr val="000000"/>
@@ -4086,7 +4111,7 @@
                 <a:ea typeface="Arial"/>
                 <a:cs typeface="Arial"/>
               </a:rPr>
-              <a:t>1,672 × 161</a:t>
+              <a:t>1,777 × 161</a:t>
             </a:r>
           </a:p>
         </p:txBody>
@@ -4126,6 +4151,7 @@
           <a:lstStyle xmlns:a="http://schemas.openxmlformats.org/drawingml/2006/main"/>
           <a:p xmlns:a="http://schemas.openxmlformats.org/drawingml/2006/main">
             <a:pPr algn="l">
+              <a:buNone/>
               <a:defRPr sz="1425" b="0">
                 <a:solidFill>
                   <a:srgbClr val="5B6470"/>
@@ -4215,6 +4241,7 @@
           <a:lstStyle xmlns:a="http://schemas.openxmlformats.org/drawingml/2006/main"/>
           <a:p xmlns:a="http://schemas.openxmlformats.org/drawingml/2006/main">
             <a:pPr algn="l">
+              <a:buNone/>
               <a:defRPr sz="2550" b="1">
                 <a:solidFill>
                   <a:srgbClr val="000000"/>
@@ -4233,7 +4260,7 @@
                 <a:ea typeface="Arial"/>
                 <a:cs typeface="Arial"/>
               </a:rPr>
-              <a:t>1,589 × 63</a:t>
+              <a:t>1,689 × 63</a:t>
             </a:r>
           </a:p>
         </p:txBody>
@@ -4273,6 +4300,7 @@
           <a:lstStyle xmlns:a="http://schemas.openxmlformats.org/drawingml/2006/main"/>
           <a:p xmlns:a="http://schemas.openxmlformats.org/drawingml/2006/main">
             <a:pPr algn="l">
+              <a:buNone/>
               <a:defRPr sz="1425" b="0">
                 <a:solidFill>
                   <a:srgbClr val="5B6470"/>
@@ -4331,6 +4359,7 @@
           <a:lstStyle xmlns:a="http://schemas.openxmlformats.org/drawingml/2006/main"/>
           <a:p xmlns:a="http://schemas.openxmlformats.org/drawingml/2006/main">
             <a:pPr algn="l">
+              <a:buNone/>
               <a:defRPr sz="1500" b="1">
                 <a:solidFill>
                   <a:srgbClr val="D69E2E"/>
@@ -4418,6 +4447,7 @@
           <a:lstStyle xmlns:a="http://schemas.openxmlformats.org/drawingml/2006/main"/>
           <a:p xmlns:a="http://schemas.openxmlformats.org/drawingml/2006/main">
             <a:pPr algn="l">
+              <a:buNone/>
               <a:defRPr sz="3150" b="1">
                 <a:solidFill>
                   <a:srgbClr val="000000"/>
@@ -4476,6 +4506,7 @@
           <a:lstStyle xmlns:a="http://schemas.openxmlformats.org/drawingml/2006/main"/>
           <a:p xmlns:a="http://schemas.openxmlformats.org/drawingml/2006/main">
             <a:pPr algn="r">
+              <a:buNone/>
               <a:defRPr sz="975" b="0">
                 <a:solidFill>
                   <a:srgbClr val="5B6470"/>
@@ -4565,6 +4596,7 @@
           <a:lstStyle xmlns:a="http://schemas.openxmlformats.org/drawingml/2006/main"/>
           <a:p xmlns:a="http://schemas.openxmlformats.org/drawingml/2006/main">
             <a:pPr algn="l">
+              <a:buNone/>
               <a:defRPr sz="2100" b="1">
                 <a:solidFill>
                   <a:srgbClr val="000000"/>
@@ -4623,6 +4655,7 @@
           <a:lstStyle xmlns:a="http://schemas.openxmlformats.org/drawingml/2006/main"/>
           <a:p xmlns:a="http://schemas.openxmlformats.org/drawingml/2006/main">
             <a:pPr algn="l">
+              <a:buNone/>
               <a:defRPr sz="1650" b="0">
                 <a:solidFill>
                   <a:srgbClr val="000000"/>
@@ -4651,6 +4684,7 @@
           </a:p>
           <a:p xmlns:a="http://schemas.openxmlformats.org/drawingml/2006/main">
             <a:pPr algn="l">
+              <a:buNone/>
               <a:defRPr sz="1650" b="0">
                 <a:solidFill>
                   <a:srgbClr val="000000"/>
@@ -4679,6 +4713,7 @@
           </a:p>
           <a:p xmlns:a="http://schemas.openxmlformats.org/drawingml/2006/main">
             <a:pPr algn="l">
+              <a:buNone/>
               <a:defRPr sz="1650" b="0">
                 <a:solidFill>
                   <a:srgbClr val="000000"/>
@@ -4707,6 +4742,7 @@
           </a:p>
           <a:p xmlns:a="http://schemas.openxmlformats.org/drawingml/2006/main">
             <a:pPr algn="l">
+              <a:buNone/>
               <a:defRPr sz="1650" b="0">
                 <a:solidFill>
                   <a:srgbClr val="000000"/>
@@ -4735,6 +4771,7 @@
           </a:p>
           <a:p xmlns:a="http://schemas.openxmlformats.org/drawingml/2006/main">
             <a:pPr algn="l">
+              <a:buNone/>
               <a:defRPr sz="1650" b="0">
                 <a:solidFill>
                   <a:srgbClr val="000000"/>
@@ -4824,6 +4861,7 @@
           <a:lstStyle xmlns:a="http://schemas.openxmlformats.org/drawingml/2006/main"/>
           <a:p xmlns:a="http://schemas.openxmlformats.org/drawingml/2006/main">
             <a:pPr algn="l">
+              <a:buNone/>
               <a:defRPr sz="2100" b="1">
                 <a:solidFill>
                   <a:srgbClr val="000000"/>
@@ -4882,6 +4920,7 @@
           <a:lstStyle xmlns:a="http://schemas.openxmlformats.org/drawingml/2006/main"/>
           <a:p xmlns:a="http://schemas.openxmlformats.org/drawingml/2006/main">
             <a:pPr algn="l">
+              <a:buNone/>
               <a:defRPr sz="1650" b="0">
                 <a:solidFill>
                   <a:srgbClr val="000000"/>
@@ -4900,7 +4939,29 @@
                 <a:ea typeface="Arial"/>
                 <a:cs typeface="Arial"/>
               </a:rPr>
-              <a:t>• 1,111 Uruguay vs 478 Argentina rows</a:t>
+              <a:t>• </a:t>
+            </a:r>
+            <a:r>
+              <a:rPr sz="1650" b="0">
+                <a:solidFill>
+                  <a:srgbClr val="000000"/>
+                </a:solidFill>
+                <a:latin typeface="Arial"/>
+                <a:ea typeface="Arial"/>
+                <a:cs typeface="Arial"/>
+              </a:rPr>
+              <a:t>1,110 Uruguay vs 579 Argentina</a:t>
+            </a:r>
+            <a:r>
+              <a:rPr sz="1650" b="0">
+                <a:solidFill>
+                  <a:srgbClr val="000000"/>
+                </a:solidFill>
+                <a:latin typeface="Arial"/>
+                <a:ea typeface="Arial"/>
+                <a:cs typeface="Arial"/>
+              </a:rPr>
+              <a:t> rows</a:t>
             </a:r>
           </a:p>
           <a:p xmlns:a="http://schemas.openxmlformats.org/drawingml/2006/main">
@@ -4910,6 +4971,7 @@
           </a:p>
           <a:p xmlns:a="http://schemas.openxmlformats.org/drawingml/2006/main">
             <a:pPr algn="l">
+              <a:buNone/>
               <a:defRPr sz="1650" b="0">
                 <a:solidFill>
                   <a:srgbClr val="000000"/>
@@ -4938,6 +5000,7 @@
           </a:p>
           <a:p xmlns:a="http://schemas.openxmlformats.org/drawingml/2006/main">
             <a:pPr algn="l">
+              <a:buNone/>
               <a:defRPr sz="1650" b="0">
                 <a:solidFill>
                   <a:srgbClr val="000000"/>
@@ -4966,6 +5029,7 @@
           </a:p>
           <a:p xmlns:a="http://schemas.openxmlformats.org/drawingml/2006/main">
             <a:pPr algn="l">
+              <a:buNone/>
               <a:defRPr sz="1650" b="0">
                 <a:solidFill>
                   <a:srgbClr val="000000"/>
@@ -4994,6 +5058,7 @@
           </a:p>
           <a:p xmlns:a="http://schemas.openxmlformats.org/drawingml/2006/main">
             <a:pPr algn="l">
+              <a:buNone/>
               <a:defRPr sz="1650" b="0">
                 <a:solidFill>
                   <a:srgbClr val="000000"/>
@@ -5081,6 +5146,7 @@
           <a:lstStyle xmlns:a="http://schemas.openxmlformats.org/drawingml/2006/main"/>
           <a:p xmlns:a="http://schemas.openxmlformats.org/drawingml/2006/main">
             <a:pPr algn="l">
+              <a:buNone/>
               <a:defRPr sz="3150" b="1">
                 <a:solidFill>
                   <a:srgbClr val="000000"/>
@@ -5139,6 +5205,7 @@
           <a:lstStyle xmlns:a="http://schemas.openxmlformats.org/drawingml/2006/main"/>
           <a:p xmlns:a="http://schemas.openxmlformats.org/drawingml/2006/main">
             <a:pPr algn="r">
+              <a:buNone/>
               <a:defRPr sz="975" b="0">
                 <a:solidFill>
                   <a:srgbClr val="5B6470"/>
@@ -5164,7 +5231,7 @@
       </p:sp>
       <p:graphicFrame>
         <p:nvGraphicFramePr>
-          <p:cNvPr id="10" name="Chart"/>
+          <p:cNvPr id="12" name="Chart"/>
           <p:cNvGraphicFramePr/>
           <p:nvPr/>
         </p:nvGraphicFramePr>
@@ -5174,7 +5241,7 @@
         </p:xfrm>
         <a:graphic xmlns:a="http://schemas.openxmlformats.org/drawingml/2006/main">
           <a:graphicData uri="http://schemas.openxmlformats.org/drawingml/2006/chart">
-            <c:chart xmlns:r="http://schemas.openxmlformats.org/officeDocument/2006/relationships" xmlns:c="http://schemas.openxmlformats.org/drawingml/2006/chart" r:id="Rb6915197a6754142"/>
+            <c:chart xmlns:r="http://schemas.openxmlformats.org/officeDocument/2006/relationships" xmlns:c="http://schemas.openxmlformats.org/drawingml/2006/chart" r:id="R41f7ba09987748e0"/>
           </a:graphicData>
         </a:graphic>
       </p:graphicFrame>
@@ -5244,6 +5311,7 @@
           <a:lstStyle xmlns:a="http://schemas.openxmlformats.org/drawingml/2006/main"/>
           <a:p xmlns:a="http://schemas.openxmlformats.org/drawingml/2006/main">
             <a:pPr algn="l">
+              <a:buNone/>
               <a:defRPr sz="2025" b="1">
                 <a:solidFill>
                   <a:srgbClr val="000000"/>
@@ -5302,6 +5370,7 @@
           <a:lstStyle xmlns:a="http://schemas.openxmlformats.org/drawingml/2006/main"/>
           <a:p xmlns:a="http://schemas.openxmlformats.org/drawingml/2006/main">
             <a:pPr algn="l">
+              <a:buNone/>
               <a:defRPr sz="1500" b="0">
                 <a:solidFill>
                   <a:srgbClr val="5B6470"/>
@@ -5330,6 +5399,7 @@
           </a:p>
           <a:p xmlns:a="http://schemas.openxmlformats.org/drawingml/2006/main">
             <a:pPr algn="l">
+              <a:buNone/>
               <a:defRPr sz="1500" b="0">
                 <a:solidFill>
                   <a:srgbClr val="5B6470"/>
@@ -5358,6 +5428,7 @@
           </a:p>
           <a:p xmlns:a="http://schemas.openxmlformats.org/drawingml/2006/main">
             <a:pPr algn="l">
+              <a:buNone/>
               <a:defRPr sz="1500" b="0">
                 <a:solidFill>
                   <a:srgbClr val="5B6470"/>
@@ -5416,6 +5487,7 @@
           <a:lstStyle xmlns:a="http://schemas.openxmlformats.org/drawingml/2006/main"/>
           <a:p xmlns:a="http://schemas.openxmlformats.org/drawingml/2006/main">
             <a:pPr algn="l">
+              <a:buNone/>
               <a:defRPr sz="1500" b="1">
                 <a:solidFill>
                   <a:srgbClr val="000000"/>
@@ -5503,6 +5575,7 @@
           <a:lstStyle xmlns:a="http://schemas.openxmlformats.org/drawingml/2006/main"/>
           <a:p xmlns:a="http://schemas.openxmlformats.org/drawingml/2006/main">
             <a:pPr algn="l">
+              <a:buNone/>
               <a:defRPr sz="3150" b="1">
                 <a:solidFill>
                   <a:srgbClr val="000000"/>
@@ -5561,6 +5634,7 @@
           <a:lstStyle xmlns:a="http://schemas.openxmlformats.org/drawingml/2006/main"/>
           <a:p xmlns:a="http://schemas.openxmlformats.org/drawingml/2006/main">
             <a:pPr algn="r">
+              <a:buNone/>
               <a:defRPr sz="975" b="0">
                 <a:solidFill>
                   <a:srgbClr val="5B6470"/>
@@ -5586,7 +5660,7 @@
       </p:sp>
       <p:graphicFrame>
         <p:nvGraphicFramePr>
-          <p:cNvPr id="14" name="Chart"/>
+          <p:cNvPr id="16" name="Chart"/>
           <p:cNvGraphicFramePr/>
           <p:nvPr/>
         </p:nvGraphicFramePr>
@@ -5596,7 +5670,7 @@
         </p:xfrm>
         <a:graphic xmlns:a="http://schemas.openxmlformats.org/drawingml/2006/main">
           <a:graphicData uri="http://schemas.openxmlformats.org/drawingml/2006/chart">
-            <c:chart xmlns:r="http://schemas.openxmlformats.org/officeDocument/2006/relationships" xmlns:c="http://schemas.openxmlformats.org/drawingml/2006/chart" r:id="R49dd170ba7e94e9f"/>
+            <c:chart xmlns:r="http://schemas.openxmlformats.org/officeDocument/2006/relationships" xmlns:c="http://schemas.openxmlformats.org/drawingml/2006/chart" r:id="Re4042d318cfe4a28"/>
           </a:graphicData>
         </a:graphic>
       </p:graphicFrame>
@@ -5635,6 +5709,7 @@
           <a:lstStyle xmlns:a="http://schemas.openxmlformats.org/drawingml/2006/main"/>
           <a:p xmlns:a="http://schemas.openxmlformats.org/drawingml/2006/main">
             <a:pPr algn="l">
+              <a:buNone/>
               <a:defRPr sz="1350" b="0">
                 <a:solidFill>
                   <a:srgbClr val="5B6470"/>
@@ -5724,6 +5799,7 @@
           <a:lstStyle xmlns:a="http://schemas.openxmlformats.org/drawingml/2006/main"/>
           <a:p xmlns:a="http://schemas.openxmlformats.org/drawingml/2006/main">
             <a:pPr algn="l">
+              <a:buNone/>
               <a:defRPr sz="1575" b="1">
                 <a:solidFill>
                   <a:srgbClr val="000000"/>
@@ -5782,6 +5858,7 @@
           <a:lstStyle xmlns:a="http://schemas.openxmlformats.org/drawingml/2006/main"/>
           <a:p xmlns:a="http://schemas.openxmlformats.org/drawingml/2006/main">
             <a:pPr algn="l">
+              <a:buNone/>
               <a:defRPr sz="1725" b="1">
                 <a:solidFill>
                   <a:srgbClr val="000000"/>
@@ -5805,6 +5882,7 @@
           </a:p>
           <a:p xmlns:a="http://schemas.openxmlformats.org/drawingml/2006/main">
             <a:pPr algn="l">
+              <a:buNone/>
               <a:defRPr sz="1725" b="1">
                 <a:solidFill>
                   <a:srgbClr val="000000"/>
@@ -5894,6 +5972,7 @@
           <a:lstStyle xmlns:a="http://schemas.openxmlformats.org/drawingml/2006/main"/>
           <a:p xmlns:a="http://schemas.openxmlformats.org/drawingml/2006/main">
             <a:pPr algn="l">
+              <a:buNone/>
               <a:defRPr sz="1575" b="1">
                 <a:solidFill>
                   <a:srgbClr val="000000"/>
@@ -5952,6 +6031,7 @@
           <a:lstStyle xmlns:a="http://schemas.openxmlformats.org/drawingml/2006/main"/>
           <a:p xmlns:a="http://schemas.openxmlformats.org/drawingml/2006/main">
             <a:pPr algn="l">
+              <a:buNone/>
               <a:defRPr sz="1725" b="1">
                 <a:solidFill>
                   <a:srgbClr val="000000"/>
@@ -5975,6 +6055,7 @@
           </a:p>
           <a:p xmlns:a="http://schemas.openxmlformats.org/drawingml/2006/main">
             <a:pPr algn="l">
+              <a:buNone/>
               <a:defRPr sz="1725" b="1">
                 <a:solidFill>
                   <a:srgbClr val="000000"/>
@@ -6033,6 +6114,7 @@
           <a:lstStyle xmlns:a="http://schemas.openxmlformats.org/drawingml/2006/main"/>
           <a:p xmlns:a="http://schemas.openxmlformats.org/drawingml/2006/main">
             <a:pPr algn="l">
+              <a:buNone/>
               <a:defRPr sz="1425" b="1">
                 <a:solidFill>
                   <a:srgbClr val="D69E2E"/>
@@ -6120,6 +6202,7 @@
           <a:lstStyle xmlns:a="http://schemas.openxmlformats.org/drawingml/2006/main"/>
           <a:p xmlns:a="http://schemas.openxmlformats.org/drawingml/2006/main">
             <a:pPr algn="l">
+              <a:buNone/>
               <a:defRPr sz="3150" b="1">
                 <a:solidFill>
                   <a:srgbClr val="000000"/>
@@ -6178,6 +6261,7 @@
           <a:lstStyle xmlns:a="http://schemas.openxmlformats.org/drawingml/2006/main"/>
           <a:p xmlns:a="http://schemas.openxmlformats.org/drawingml/2006/main">
             <a:pPr algn="r">
+              <a:buNone/>
               <a:defRPr sz="975" b="0">
                 <a:solidFill>
                   <a:srgbClr val="5B6470"/>
@@ -6236,6 +6320,7 @@
           <a:lstStyle xmlns:a="http://schemas.openxmlformats.org/drawingml/2006/main"/>
           <a:p xmlns:a="http://schemas.openxmlformats.org/drawingml/2006/main">
             <a:pPr algn="l">
+              <a:buNone/>
               <a:defRPr sz="1800" b="0">
                 <a:solidFill>
                   <a:srgbClr val="5B6470"/>
@@ -6325,6 +6410,7 @@
           <a:lstStyle xmlns:a="http://schemas.openxmlformats.org/drawingml/2006/main"/>
           <a:p xmlns:a="http://schemas.openxmlformats.org/drawingml/2006/main">
             <a:pPr algn="l">
+              <a:buNone/>
               <a:defRPr sz="3900" b="1">
                 <a:solidFill>
                   <a:srgbClr val="3D8DFF"/>
@@ -6343,7 +6429,7 @@
                 <a:ea typeface="Arial"/>
                 <a:cs typeface="Arial"/>
               </a:rPr>
-              <a:t>0.623</a:t>
+              <a:t>0.475</a:t>
             </a:r>
           </a:p>
         </p:txBody>
@@ -6383,6 +6469,7 @@
           <a:lstStyle xmlns:a="http://schemas.openxmlformats.org/drawingml/2006/main"/>
           <a:p xmlns:a="http://schemas.openxmlformats.org/drawingml/2006/main">
             <a:pPr algn="l">
+              <a:buNone/>
               <a:defRPr sz="1875" b="1">
                 <a:solidFill>
                   <a:srgbClr val="000000"/>
@@ -6441,6 +6528,7 @@
           <a:lstStyle xmlns:a="http://schemas.openxmlformats.org/drawingml/2006/main"/>
           <a:p xmlns:a="http://schemas.openxmlformats.org/drawingml/2006/main">
             <a:pPr algn="l">
+              <a:buNone/>
               <a:defRPr sz="1350" b="0">
                 <a:solidFill>
                   <a:srgbClr val="5B6470"/>
@@ -6530,6 +6618,7 @@
           <a:lstStyle xmlns:a="http://schemas.openxmlformats.org/drawingml/2006/main"/>
           <a:p xmlns:a="http://schemas.openxmlformats.org/drawingml/2006/main">
             <a:pPr algn="l">
+              <a:buNone/>
               <a:defRPr sz="3900" b="1">
                 <a:solidFill>
                   <a:srgbClr val="3D8DFF"/>
@@ -6548,7 +6637,7 @@
                 <a:ea typeface="Arial"/>
                 <a:cs typeface="Arial"/>
               </a:rPr>
-              <a:t>$93,161</a:t>
+              <a:t>$105,473</a:t>
             </a:r>
           </a:p>
         </p:txBody>
@@ -6588,6 +6677,7 @@
           <a:lstStyle xmlns:a="http://schemas.openxmlformats.org/drawingml/2006/main"/>
           <a:p xmlns:a="http://schemas.openxmlformats.org/drawingml/2006/main">
             <a:pPr algn="l">
+              <a:buNone/>
               <a:defRPr sz="1875" b="1">
                 <a:solidFill>
                   <a:srgbClr val="000000"/>
@@ -6646,6 +6736,7 @@
           <a:lstStyle xmlns:a="http://schemas.openxmlformats.org/drawingml/2006/main"/>
           <a:p xmlns:a="http://schemas.openxmlformats.org/drawingml/2006/main">
             <a:pPr algn="l">
+              <a:buNone/>
               <a:defRPr sz="1350" b="0">
                 <a:solidFill>
                   <a:srgbClr val="5B6470"/>
@@ -6735,6 +6826,7 @@
           <a:lstStyle xmlns:a="http://schemas.openxmlformats.org/drawingml/2006/main"/>
           <a:p xmlns:a="http://schemas.openxmlformats.org/drawingml/2006/main">
             <a:pPr algn="l">
+              <a:buNone/>
               <a:defRPr sz="3900" b="1">
                 <a:solidFill>
                   <a:srgbClr val="3D8DFF"/>
@@ -6753,7 +6845,7 @@
                 <a:ea typeface="Arial"/>
                 <a:cs typeface="Arial"/>
               </a:rPr>
-              <a:t>26.2%</a:t>
+              <a:t>27.2%</a:t>
             </a:r>
           </a:p>
         </p:txBody>
@@ -6793,6 +6885,7 @@
           <a:lstStyle xmlns:a="http://schemas.openxmlformats.org/drawingml/2006/main"/>
           <a:p xmlns:a="http://schemas.openxmlformats.org/drawingml/2006/main">
             <a:pPr algn="l">
+              <a:buNone/>
               <a:defRPr sz="1875" b="1">
                 <a:solidFill>
                   <a:srgbClr val="000000"/>
@@ -6851,6 +6944,7 @@
           <a:lstStyle xmlns:a="http://schemas.openxmlformats.org/drawingml/2006/main"/>
           <a:p xmlns:a="http://schemas.openxmlformats.org/drawingml/2006/main">
             <a:pPr algn="l">
+              <a:buNone/>
               <a:defRPr sz="1350" b="0">
                 <a:solidFill>
                   <a:srgbClr val="5B6470"/>
@@ -6909,6 +7003,7 @@
           <a:lstStyle xmlns:a="http://schemas.openxmlformats.org/drawingml/2006/main"/>
           <a:p xmlns:a="http://schemas.openxmlformats.org/drawingml/2006/main">
             <a:pPr algn="l">
+              <a:buNone/>
               <a:defRPr sz="1500" b="1">
                 <a:solidFill>
                   <a:srgbClr val="000000"/>
@@ -6927,7 +7022,7 @@
                 <a:ea typeface="Arial"/>
                 <a:cs typeface="Arial"/>
               </a:rPr>
-              <a:t>Cross-validation mean R²: approximately 0.636</a:t>
+              <a:t>Cross-validation mean R²: 0.628</a:t>
             </a:r>
           </a:p>
         </p:txBody>
@@ -6996,6 +7091,7 @@
           <a:lstStyle xmlns:a="http://schemas.openxmlformats.org/drawingml/2006/main"/>
           <a:p xmlns:a="http://schemas.openxmlformats.org/drawingml/2006/main">
             <a:pPr algn="l">
+              <a:buNone/>
               <a:defRPr sz="3150" b="1">
                 <a:solidFill>
                   <a:srgbClr val="000000"/>
@@ -7054,6 +7150,7 @@
           <a:lstStyle xmlns:a="http://schemas.openxmlformats.org/drawingml/2006/main"/>
           <a:p xmlns:a="http://schemas.openxmlformats.org/drawingml/2006/main">
             <a:pPr algn="r">
+              <a:buNone/>
               <a:defRPr sz="975" b="0">
                 <a:solidFill>
                   <a:srgbClr val="5B6470"/>
@@ -7143,6 +7240,7 @@
           <a:lstStyle xmlns:a="http://schemas.openxmlformats.org/drawingml/2006/main"/>
           <a:p xmlns:a="http://schemas.openxmlformats.org/drawingml/2006/main">
             <a:pPr algn="l">
+              <a:buNone/>
               <a:defRPr sz="2175" b="1">
                 <a:solidFill>
                   <a:srgbClr val="000000"/>
@@ -7201,6 +7299,7 @@
           <a:lstStyle xmlns:a="http://schemas.openxmlformats.org/drawingml/2006/main"/>
           <a:p xmlns:a="http://schemas.openxmlformats.org/drawingml/2006/main">
             <a:pPr algn="l">
+              <a:buNone/>
               <a:defRPr sz="1725" b="0">
                 <a:solidFill>
                   <a:srgbClr val="000000"/>
@@ -7229,6 +7328,7 @@
           </a:p>
           <a:p xmlns:a="http://schemas.openxmlformats.org/drawingml/2006/main">
             <a:pPr algn="l">
+              <a:buNone/>
               <a:defRPr sz="1725" b="0">
                 <a:solidFill>
                   <a:srgbClr val="000000"/>
@@ -7257,6 +7357,7 @@
           </a:p>
           <a:p xmlns:a="http://schemas.openxmlformats.org/drawingml/2006/main">
             <a:pPr algn="l">
+              <a:buNone/>
               <a:defRPr sz="1725" b="0">
                 <a:solidFill>
                   <a:srgbClr val="000000"/>
@@ -7285,6 +7386,7 @@
           </a:p>
           <a:p xmlns:a="http://schemas.openxmlformats.org/drawingml/2006/main">
             <a:pPr algn="l">
+              <a:buNone/>
               <a:defRPr sz="1725" b="0">
                 <a:solidFill>
                   <a:srgbClr val="000000"/>
@@ -7313,6 +7415,7 @@
           </a:p>
           <a:p xmlns:a="http://schemas.openxmlformats.org/drawingml/2006/main">
             <a:pPr algn="l">
+              <a:buNone/>
               <a:defRPr sz="1725" b="0">
                 <a:solidFill>
                   <a:srgbClr val="000000"/>
@@ -7331,7 +7434,18 @@
                 <a:ea typeface="Arial"/>
                 <a:cs typeface="Arial"/>
               </a:rPr>
-              <a:t>• Specification and slides</a:t>
+              <a:t>• </a:t>
+            </a:r>
+            <a:r>
+              <a:rPr sz="1725" b="0">
+                <a:solidFill>
+                  <a:srgbClr val="000000"/>
+                </a:solidFill>
+                <a:latin typeface="Arial"/>
+                <a:ea typeface="Arial"/>
+                <a:cs typeface="Arial"/>
+              </a:rPr>
+              <a:t>Specification, slides + video</a:t>
             </a:r>
           </a:p>
         </p:txBody>
@@ -7402,6 +7516,7 @@
           <a:lstStyle xmlns:a="http://schemas.openxmlformats.org/drawingml/2006/main"/>
           <a:p xmlns:a="http://schemas.openxmlformats.org/drawingml/2006/main">
             <a:pPr algn="l">
+              <a:buNone/>
               <a:defRPr sz="2175" b="1">
                 <a:solidFill>
                   <a:srgbClr val="000000"/>
@@ -7460,6 +7575,7 @@
           <a:lstStyle xmlns:a="http://schemas.openxmlformats.org/drawingml/2006/main"/>
           <a:p xmlns:a="http://schemas.openxmlformats.org/drawingml/2006/main">
             <a:pPr algn="l">
+              <a:buNone/>
               <a:defRPr sz="1650" b="0">
                 <a:solidFill>
                   <a:srgbClr val="5B6470"/>
@@ -7488,6 +7604,7 @@
           </a:p>
           <a:p xmlns:a="http://schemas.openxmlformats.org/drawingml/2006/main">
             <a:pPr algn="l">
+              <a:buNone/>
               <a:defRPr sz="1650" b="0">
                 <a:solidFill>
                   <a:srgbClr val="5B6470"/>
@@ -7516,6 +7633,7 @@
           </a:p>
           <a:p xmlns:a="http://schemas.openxmlformats.org/drawingml/2006/main">
             <a:pPr algn="l">
+              <a:buNone/>
               <a:defRPr sz="1650" b="0">
                 <a:solidFill>
                   <a:srgbClr val="5B6470"/>
@@ -7574,6 +7692,7 @@
           <a:lstStyle xmlns:a="http://schemas.openxmlformats.org/drawingml/2006/main"/>
           <a:p xmlns:a="http://schemas.openxmlformats.org/drawingml/2006/main">
             <a:pPr algn="ctr">
+              <a:buNone/>
               <a:defRPr sz="1950" b="1">
                 <a:solidFill>
                   <a:srgbClr val="3D8DFF"/>

</xml_diff>